<commit_message>
docs: align case timeline with August 10 kickoff
</commit_message>
<xml_diff>
--- a/Task2/nairobi-slide.pptx
+++ b/Task2/nairobi-slide.pptx
@@ -2,13 +2,13 @@
 <file path=ppt/presentation.xml><?xml version="1.0" encoding="utf-8"?>
 <p:presentation xmlns:p="http://schemas.openxmlformats.org/presentationml/2006/main">
   <p:sldMasterIdLst>
-    <p:sldMasterId xmlns:r="http://schemas.openxmlformats.org/officeDocument/2006/relationships" id="2147483648" r:id="Rb4f51ffed58f4018"/>
+    <p:sldMasterId xmlns:r="http://schemas.openxmlformats.org/officeDocument/2006/relationships" id="2147483648" r:id="R3a31dfe0806d45b2"/>
   </p:sldMasterIdLst>
   <p:notesMasterIdLst>
-    <p:notesMasterId xmlns:r="http://schemas.openxmlformats.org/officeDocument/2006/relationships" r:id="R2422ad11802149a0"/>
+    <p:notesMasterId xmlns:r="http://schemas.openxmlformats.org/officeDocument/2006/relationships" r:id="R1378cc47b78f444f"/>
   </p:notesMasterIdLst>
   <p:sldIdLst>
-    <p:sldId xmlns:r="http://schemas.openxmlformats.org/officeDocument/2006/relationships" id="256" r:id="R25d89ccd3ac048e7"/>
+    <p:sldId xmlns:r="http://schemas.openxmlformats.org/officeDocument/2006/relationships" id="256" r:id="Rf6abaef583d94323"/>
   </p:sldIdLst>
   <p:sldSz cx="12192000" cy="6858000"/>
   <p:notesSz cx="6858000" cy="9144000"/>
@@ -442,7 +442,7 @@
           <a:lstStyle xmlns:a="http://schemas.openxmlformats.org/drawingml/2006/main"/>
           <a:p xmlns:a="http://schemas.openxmlformats.org/drawingml/2006/main">
             <a:r>
-              <a:t>Основания: A1 с.1–3, A3 с.2, A5 с.1–3, A6 с.1–2, A7, A8; Task1 Canvas 6–9, C04–C05. Расчёт: tco-model.xlsx, Контроль C6:E22. Общий прогноз 41,3М заказов за 5 лет, AOV $25, PSP 2,2% all-in (гипотеза), ФОТ $5000/FTE/мес и +30%/год. TCO полный A/B/C = 38,243/39,763/45,016 млн; без PSP с резервом = 13,256/14,776/20,029 млн. Техника ≤$5000 первые 6 мес требует ограничить пилот 2000 заказов/мес; A при &gt;9000 требует нового бюджета. Oracle EE 4 Processor в C — допущение, не указание редакции CTO; прайс 47500 и 10450 поддержки, без RAC/ADG. Даже без Oracle C =15700/мес. https://www.oracle.com/europe/a/ocom/docs/corporate/pricing/technology-price-list-070617.pdf (15.09.2026, с.2); https://flutterwave.com/ke/pricing (mobile money 2,9% до налогов); https://www.cncf.io/training/certification/software-conformance/; проверено05.10.2026. Дата встречи12.10, дата запуска15.10: готовность неизвестна. Сроки8/12/24 недели от готовой команды/договоров; исключение SLO99,9/RTO60/RPO15 должно быть принято инвестором. ПриложениеА—TCO инструкция, Б—FMEA. Полный транскрипт1346 слов в nairobi-script.md.</a:t>
+              <a:t>Основания: A1 с.1–3, A3 с.2, A5 с.1–3, A6 с.1–2, A7, A8; Task1 Canvas 6–9, C04–C05. Расчёт: tco-model.xlsx, Контроль C6:E22. Общий прогноз 41,3М заказов за 5 лет, AOV $25, PSP 2,2% all-in (гипотеза), ФОТ $5000/FTE/мес и +30%/год. TCO полный A/B/C = 38,243/39,763/45,016 млн; без PSP с резервом = 13,256/14,776/20,029 млн. Техника ≤$5000 первые 6 мес требует ограничить пилот 2000 заказов/мес; A при &gt;9000 требует нового бюджета. Oracle EE 4 Processor в C — допущение, не указание редакции CTO; прайс 47500 и 10450 поддержки, без RAC/ADG. Даже без Oracle C =15700/мес. https://www.oracle.com/europe/a/ocom/docs/corporate/pricing/technology-price-list-070617.pdf (15.09.2026, с.2); https://flutterwave.com/ke/pricing (mobile money 2,9% до налогов); https://www.cncf.io/training/certification/software-conformance/; Фактически проверено05.10.2026, позднее августовского начала кейса. Oracle прайс15.09.2026 является поздним уточнением. Для первоначального выбора цены — оценки до исторической редакции/оферты. Кейс начинается 10.08.2026. Встреча в Найроби ориентир 17.08, не подтверждённая дата. При готовности условий старта 10.08 A готов 05.10 (10 дней резерва), B 02.11 (18 дней опоздания), C 25.01.2027 (102 дня опоздания). При старте A после встречи 17.08 готовность 12.10 и резерв три дня. Предварительная проверка продукта 12.10, решение о допуске 14.10, открытие 15.10. Сроки8/12/24 недели от готовой команды/договоров; исключение SLO99,9/RTO60/RPO15 должно быть принято инвестором. ПриложениеА—TCO инструкция, Б—FMEA. Речь на десять минут в nairobi-script.md; календарь и допущения в ../case-calendar.md.</a:t>
             </a:r>
           </a:p>
         </p:txBody>
@@ -561,6 +561,7 @@
                 <a:spcPts val="0"/>
               </a:spcAft>
               <a:buNone/>
+              <a:defRPr/>
             </a:lvl1pPr>
             <a:lvl2pPr marL="0" indent="0">
               <a:lnSpc>
@@ -573,6 +574,7 @@
                 <a:spcPts val="0"/>
               </a:spcAft>
               <a:buNone/>
+              <a:defRPr/>
             </a:lvl2pPr>
             <a:lvl3pPr marL="0" indent="0">
               <a:lnSpc>
@@ -585,6 +587,7 @@
                 <a:spcPts val="0"/>
               </a:spcAft>
               <a:buNone/>
+              <a:defRPr/>
             </a:lvl3pPr>
             <a:lvl4pPr marL="0" indent="0">
               <a:lnSpc>
@@ -597,6 +600,7 @@
                 <a:spcPts val="0"/>
               </a:spcAft>
               <a:buNone/>
+              <a:defRPr/>
             </a:lvl4pPr>
             <a:lvl5pPr marL="0" indent="0">
               <a:lnSpc>
@@ -609,6 +613,7 @@
                 <a:spcPts val="0"/>
               </a:spcAft>
               <a:buNone/>
+              <a:defRPr/>
             </a:lvl5pPr>
             <a:lvl6pPr marL="0" indent="0">
               <a:lnSpc>
@@ -621,6 +626,7 @@
                 <a:spcPts val="0"/>
               </a:spcAft>
               <a:buNone/>
+              <a:defRPr/>
             </a:lvl6pPr>
             <a:lvl7pPr marL="0" indent="0">
               <a:lnSpc>
@@ -633,6 +639,7 @@
                 <a:spcPts val="0"/>
               </a:spcAft>
               <a:buNone/>
+              <a:defRPr/>
             </a:lvl7pPr>
             <a:lvl8pPr marL="0" indent="0">
               <a:lnSpc>
@@ -645,6 +652,7 @@
                 <a:spcPts val="0"/>
               </a:spcAft>
               <a:buNone/>
+              <a:defRPr/>
             </a:lvl8pPr>
             <a:lvl9pPr marL="0" indent="0">
               <a:lnSpc>
@@ -657,6 +665,7 @@
                 <a:spcPts val="0"/>
               </a:spcAft>
               <a:buNone/>
+              <a:defRPr/>
             </a:lvl9pPr>
           </a:lstStyle>
           <a:p xmlns:a="http://schemas.openxmlformats.org/drawingml/2006/main"/>
@@ -708,6 +717,7 @@
                 <a:spcPts val="0"/>
               </a:spcAft>
               <a:buNone/>
+              <a:defRPr/>
             </a:lvl1pPr>
             <a:lvl2pPr marL="0" indent="0">
               <a:lnSpc>
@@ -720,6 +730,7 @@
                 <a:spcPts val="0"/>
               </a:spcAft>
               <a:buNone/>
+              <a:defRPr/>
             </a:lvl2pPr>
             <a:lvl3pPr marL="0" indent="0">
               <a:lnSpc>
@@ -732,6 +743,7 @@
                 <a:spcPts val="0"/>
               </a:spcAft>
               <a:buNone/>
+              <a:defRPr/>
             </a:lvl3pPr>
             <a:lvl4pPr marL="0" indent="0">
               <a:lnSpc>
@@ -744,6 +756,7 @@
                 <a:spcPts val="0"/>
               </a:spcAft>
               <a:buNone/>
+              <a:defRPr/>
             </a:lvl4pPr>
             <a:lvl5pPr marL="0" indent="0">
               <a:lnSpc>
@@ -756,6 +769,7 @@
                 <a:spcPts val="0"/>
               </a:spcAft>
               <a:buNone/>
+              <a:defRPr/>
             </a:lvl5pPr>
             <a:lvl6pPr marL="0" indent="0">
               <a:lnSpc>
@@ -768,6 +782,7 @@
                 <a:spcPts val="0"/>
               </a:spcAft>
               <a:buNone/>
+              <a:defRPr/>
             </a:lvl6pPr>
             <a:lvl7pPr marL="0" indent="0">
               <a:lnSpc>
@@ -780,6 +795,7 @@
                 <a:spcPts val="0"/>
               </a:spcAft>
               <a:buNone/>
+              <a:defRPr/>
             </a:lvl7pPr>
             <a:lvl8pPr marL="0" indent="0">
               <a:lnSpc>
@@ -792,6 +808,7 @@
                 <a:spcPts val="0"/>
               </a:spcAft>
               <a:buNone/>
+              <a:defRPr/>
             </a:lvl8pPr>
             <a:lvl9pPr marL="0" indent="0">
               <a:lnSpc>
@@ -804,6 +821,7 @@
                 <a:spcPts val="0"/>
               </a:spcAft>
               <a:buNone/>
+              <a:defRPr/>
             </a:lvl9pPr>
           </a:lstStyle>
           <a:p xmlns:a="http://schemas.openxmlformats.org/drawingml/2006/main"/>
@@ -903,6 +921,7 @@
                 <a:spcPts val="0"/>
               </a:spcAft>
               <a:buNone/>
+              <a:defRPr/>
             </a:lvl1pPr>
             <a:lvl2pPr marL="0" indent="0">
               <a:lnSpc>
@@ -915,6 +934,7 @@
                 <a:spcPts val="0"/>
               </a:spcAft>
               <a:buNone/>
+              <a:defRPr/>
             </a:lvl2pPr>
             <a:lvl3pPr marL="0" indent="0">
               <a:lnSpc>
@@ -927,6 +947,7 @@
                 <a:spcPts val="0"/>
               </a:spcAft>
               <a:buNone/>
+              <a:defRPr/>
             </a:lvl3pPr>
             <a:lvl4pPr marL="0" indent="0">
               <a:lnSpc>
@@ -939,6 +960,7 @@
                 <a:spcPts val="0"/>
               </a:spcAft>
               <a:buNone/>
+              <a:defRPr/>
             </a:lvl4pPr>
             <a:lvl5pPr marL="0" indent="0">
               <a:lnSpc>
@@ -951,6 +973,7 @@
                 <a:spcPts val="0"/>
               </a:spcAft>
               <a:buNone/>
+              <a:defRPr/>
             </a:lvl5pPr>
             <a:lvl6pPr marL="0" indent="0">
               <a:lnSpc>
@@ -963,6 +986,7 @@
                 <a:spcPts val="0"/>
               </a:spcAft>
               <a:buNone/>
+              <a:defRPr/>
             </a:lvl6pPr>
             <a:lvl7pPr marL="0" indent="0">
               <a:lnSpc>
@@ -975,6 +999,7 @@
                 <a:spcPts val="0"/>
               </a:spcAft>
               <a:buNone/>
+              <a:defRPr/>
             </a:lvl7pPr>
             <a:lvl8pPr marL="0" indent="0">
               <a:lnSpc>
@@ -987,6 +1012,7 @@
                 <a:spcPts val="0"/>
               </a:spcAft>
               <a:buNone/>
+              <a:defRPr/>
             </a:lvl8pPr>
             <a:lvl9pPr marL="0" indent="0">
               <a:lnSpc>
@@ -999,6 +1025,7 @@
                 <a:spcPts val="0"/>
               </a:spcAft>
               <a:buNone/>
+              <a:defRPr/>
             </a:lvl9pPr>
           </a:lstStyle>
           <a:p xmlns:a="http://schemas.openxmlformats.org/drawingml/2006/main"/>
@@ -1098,6 +1125,7 @@
                 <a:spcPts val="0"/>
               </a:spcAft>
               <a:buNone/>
+              <a:defRPr/>
             </a:lvl1pPr>
             <a:lvl2pPr marL="0" indent="0">
               <a:lnSpc>
@@ -1110,6 +1138,7 @@
                 <a:spcPts val="0"/>
               </a:spcAft>
               <a:buNone/>
+              <a:defRPr/>
             </a:lvl2pPr>
             <a:lvl3pPr marL="0" indent="0">
               <a:lnSpc>
@@ -1122,6 +1151,7 @@
                 <a:spcPts val="0"/>
               </a:spcAft>
               <a:buNone/>
+              <a:defRPr/>
             </a:lvl3pPr>
             <a:lvl4pPr marL="0" indent="0">
               <a:lnSpc>
@@ -1134,6 +1164,7 @@
                 <a:spcPts val="0"/>
               </a:spcAft>
               <a:buNone/>
+              <a:defRPr/>
             </a:lvl4pPr>
             <a:lvl5pPr marL="0" indent="0">
               <a:lnSpc>
@@ -1146,6 +1177,7 @@
                 <a:spcPts val="0"/>
               </a:spcAft>
               <a:buNone/>
+              <a:defRPr/>
             </a:lvl5pPr>
             <a:lvl6pPr marL="0" indent="0">
               <a:lnSpc>
@@ -1158,6 +1190,7 @@
                 <a:spcPts val="0"/>
               </a:spcAft>
               <a:buNone/>
+              <a:defRPr/>
             </a:lvl6pPr>
             <a:lvl7pPr marL="0" indent="0">
               <a:lnSpc>
@@ -1170,6 +1203,7 @@
                 <a:spcPts val="0"/>
               </a:spcAft>
               <a:buNone/>
+              <a:defRPr/>
             </a:lvl7pPr>
             <a:lvl8pPr marL="0" indent="0">
               <a:lnSpc>
@@ -1182,6 +1216,7 @@
                 <a:spcPts val="0"/>
               </a:spcAft>
               <a:buNone/>
+              <a:defRPr/>
             </a:lvl8pPr>
             <a:lvl9pPr marL="0" indent="0">
               <a:lnSpc>
@@ -1194,6 +1229,7 @@
                 <a:spcPts val="0"/>
               </a:spcAft>
               <a:buNone/>
+              <a:defRPr/>
             </a:lvl9pPr>
           </a:lstStyle>
           <a:p xmlns:a="http://schemas.openxmlformats.org/drawingml/2006/main"/>
@@ -1245,6 +1281,7 @@
                 <a:spcPts val="1200"/>
               </a:spcAft>
               <a:buChar char="•"/>
+              <a:defRPr/>
             </a:lvl1pPr>
             <a:lvl2pPr marL="533400" indent="-228600">
               <a:lnSpc>
@@ -1257,6 +1294,7 @@
                 <a:spcPts val="1200"/>
               </a:spcAft>
               <a:buChar char="•"/>
+              <a:defRPr/>
             </a:lvl2pPr>
             <a:lvl3pPr marL="838200" indent="-228600">
               <a:lnSpc>
@@ -1269,6 +1307,7 @@
                 <a:spcPts val="1200"/>
               </a:spcAft>
               <a:buChar char="•"/>
+              <a:defRPr/>
             </a:lvl3pPr>
             <a:lvl4pPr marL="1143000" indent="-228600">
               <a:lnSpc>
@@ -1281,6 +1320,7 @@
                 <a:spcPts val="1200"/>
               </a:spcAft>
               <a:buChar char="•"/>
+              <a:defRPr/>
             </a:lvl4pPr>
             <a:lvl5pPr marL="1447800" indent="-228600">
               <a:lnSpc>
@@ -1293,6 +1333,7 @@
                 <a:spcPts val="1200"/>
               </a:spcAft>
               <a:buChar char="•"/>
+              <a:defRPr/>
             </a:lvl5pPr>
             <a:lvl6pPr marL="1752600" indent="-228600">
               <a:lnSpc>
@@ -1305,6 +1346,7 @@
                 <a:spcPts val="1200"/>
               </a:spcAft>
               <a:buChar char="•"/>
+              <a:defRPr/>
             </a:lvl6pPr>
             <a:lvl7pPr marL="2057400" indent="-228600">
               <a:lnSpc>
@@ -1317,6 +1359,7 @@
                 <a:spcPts val="1200"/>
               </a:spcAft>
               <a:buChar char="•"/>
+              <a:defRPr/>
             </a:lvl7pPr>
             <a:lvl8pPr marL="2362200" indent="-228600">
               <a:lnSpc>
@@ -1329,6 +1372,7 @@
                 <a:spcPts val="1200"/>
               </a:spcAft>
               <a:buChar char="•"/>
+              <a:defRPr/>
             </a:lvl8pPr>
             <a:lvl9pPr marL="2667000" indent="-228600">
               <a:lnSpc>
@@ -1341,6 +1385,7 @@
                 <a:spcPts val="1200"/>
               </a:spcAft>
               <a:buChar char="•"/>
+              <a:defRPr/>
             </a:lvl9pPr>
           </a:lstStyle>
           <a:p xmlns:a="http://schemas.openxmlformats.org/drawingml/2006/main"/>
@@ -1440,6 +1485,7 @@
                 <a:spcPts val="0"/>
               </a:spcAft>
               <a:buNone/>
+              <a:defRPr/>
             </a:lvl1pPr>
             <a:lvl2pPr marL="0" indent="0">
               <a:lnSpc>
@@ -1452,6 +1498,7 @@
                 <a:spcPts val="0"/>
               </a:spcAft>
               <a:buNone/>
+              <a:defRPr/>
             </a:lvl2pPr>
             <a:lvl3pPr marL="0" indent="0">
               <a:lnSpc>
@@ -1464,6 +1511,7 @@
                 <a:spcPts val="0"/>
               </a:spcAft>
               <a:buNone/>
+              <a:defRPr/>
             </a:lvl3pPr>
             <a:lvl4pPr marL="0" indent="0">
               <a:lnSpc>
@@ -1476,6 +1524,7 @@
                 <a:spcPts val="0"/>
               </a:spcAft>
               <a:buNone/>
+              <a:defRPr/>
             </a:lvl4pPr>
             <a:lvl5pPr marL="0" indent="0">
               <a:lnSpc>
@@ -1488,6 +1537,7 @@
                 <a:spcPts val="0"/>
               </a:spcAft>
               <a:buNone/>
+              <a:defRPr/>
             </a:lvl5pPr>
             <a:lvl6pPr marL="0" indent="0">
               <a:lnSpc>
@@ -1500,6 +1550,7 @@
                 <a:spcPts val="0"/>
               </a:spcAft>
               <a:buNone/>
+              <a:defRPr/>
             </a:lvl6pPr>
             <a:lvl7pPr marL="0" indent="0">
               <a:lnSpc>
@@ -1512,6 +1563,7 @@
                 <a:spcPts val="0"/>
               </a:spcAft>
               <a:buNone/>
+              <a:defRPr/>
             </a:lvl7pPr>
             <a:lvl8pPr marL="0" indent="0">
               <a:lnSpc>
@@ -1524,6 +1576,7 @@
                 <a:spcPts val="0"/>
               </a:spcAft>
               <a:buNone/>
+              <a:defRPr/>
             </a:lvl8pPr>
             <a:lvl9pPr marL="0" indent="0">
               <a:lnSpc>
@@ -1536,6 +1589,7 @@
                 <a:spcPts val="0"/>
               </a:spcAft>
               <a:buNone/>
+              <a:defRPr/>
             </a:lvl9pPr>
           </a:lstStyle>
           <a:p xmlns:a="http://schemas.openxmlformats.org/drawingml/2006/main"/>
@@ -1587,6 +1641,7 @@
                 <a:spcPts val="1200"/>
               </a:spcAft>
               <a:buChar char="•"/>
+              <a:defRPr/>
             </a:lvl1pPr>
             <a:lvl2pPr marL="533400" indent="-228600">
               <a:lnSpc>
@@ -1599,6 +1654,7 @@
                 <a:spcPts val="1200"/>
               </a:spcAft>
               <a:buChar char="•"/>
+              <a:defRPr/>
             </a:lvl2pPr>
             <a:lvl3pPr marL="838200" indent="-228600">
               <a:lnSpc>
@@ -1611,6 +1667,7 @@
                 <a:spcPts val="1200"/>
               </a:spcAft>
               <a:buChar char="•"/>
+              <a:defRPr/>
             </a:lvl3pPr>
             <a:lvl4pPr marL="1143000" indent="-228600">
               <a:lnSpc>
@@ -1623,6 +1680,7 @@
                 <a:spcPts val="1200"/>
               </a:spcAft>
               <a:buChar char="•"/>
+              <a:defRPr/>
             </a:lvl4pPr>
             <a:lvl5pPr marL="1447800" indent="-228600">
               <a:lnSpc>
@@ -1635,6 +1693,7 @@
                 <a:spcPts val="1200"/>
               </a:spcAft>
               <a:buChar char="•"/>
+              <a:defRPr/>
             </a:lvl5pPr>
             <a:lvl6pPr marL="1752600" indent="-228600">
               <a:lnSpc>
@@ -1647,6 +1706,7 @@
                 <a:spcPts val="1200"/>
               </a:spcAft>
               <a:buChar char="•"/>
+              <a:defRPr/>
             </a:lvl6pPr>
             <a:lvl7pPr marL="2057400" indent="-228600">
               <a:lnSpc>
@@ -1659,6 +1719,7 @@
                 <a:spcPts val="1200"/>
               </a:spcAft>
               <a:buChar char="•"/>
+              <a:defRPr/>
             </a:lvl7pPr>
             <a:lvl8pPr marL="2362200" indent="-228600">
               <a:lnSpc>
@@ -1671,6 +1732,7 @@
                 <a:spcPts val="1200"/>
               </a:spcAft>
               <a:buChar char="•"/>
+              <a:defRPr/>
             </a:lvl8pPr>
             <a:lvl9pPr marL="2667000" indent="-228600">
               <a:lnSpc>
@@ -1683,6 +1745,7 @@
                 <a:spcPts val="1200"/>
               </a:spcAft>
               <a:buChar char="•"/>
+              <a:defRPr/>
             </a:lvl9pPr>
           </a:lstStyle>
           <a:p xmlns:a="http://schemas.openxmlformats.org/drawingml/2006/main"/>
@@ -1734,6 +1797,7 @@
                 <a:spcPts val="1200"/>
               </a:spcAft>
               <a:buChar char="•"/>
+              <a:defRPr/>
             </a:lvl1pPr>
             <a:lvl2pPr marL="533400" indent="-228600">
               <a:lnSpc>
@@ -1746,6 +1810,7 @@
                 <a:spcPts val="1200"/>
               </a:spcAft>
               <a:buChar char="•"/>
+              <a:defRPr/>
             </a:lvl2pPr>
             <a:lvl3pPr marL="838200" indent="-228600">
               <a:lnSpc>
@@ -1758,6 +1823,7 @@
                 <a:spcPts val="1200"/>
               </a:spcAft>
               <a:buChar char="•"/>
+              <a:defRPr/>
             </a:lvl3pPr>
             <a:lvl4pPr marL="1143000" indent="-228600">
               <a:lnSpc>
@@ -1770,6 +1836,7 @@
                 <a:spcPts val="1200"/>
               </a:spcAft>
               <a:buChar char="•"/>
+              <a:defRPr/>
             </a:lvl4pPr>
             <a:lvl5pPr marL="1447800" indent="-228600">
               <a:lnSpc>
@@ -1782,6 +1849,7 @@
                 <a:spcPts val="1200"/>
               </a:spcAft>
               <a:buChar char="•"/>
+              <a:defRPr/>
             </a:lvl5pPr>
             <a:lvl6pPr marL="1752600" indent="-228600">
               <a:lnSpc>
@@ -1794,6 +1862,7 @@
                 <a:spcPts val="1200"/>
               </a:spcAft>
               <a:buChar char="•"/>
+              <a:defRPr/>
             </a:lvl6pPr>
             <a:lvl7pPr marL="2057400" indent="-228600">
               <a:lnSpc>
@@ -1806,6 +1875,7 @@
                 <a:spcPts val="1200"/>
               </a:spcAft>
               <a:buChar char="•"/>
+              <a:defRPr/>
             </a:lvl7pPr>
             <a:lvl8pPr marL="2362200" indent="-228600">
               <a:lnSpc>
@@ -1818,6 +1888,7 @@
                 <a:spcPts val="1200"/>
               </a:spcAft>
               <a:buChar char="•"/>
+              <a:defRPr/>
             </a:lvl8pPr>
             <a:lvl9pPr marL="2667000" indent="-228600">
               <a:lnSpc>
@@ -1830,6 +1901,7 @@
                 <a:spcPts val="1200"/>
               </a:spcAft>
               <a:buChar char="•"/>
+              <a:defRPr/>
             </a:lvl9pPr>
           </a:lstStyle>
           <a:p xmlns:a="http://schemas.openxmlformats.org/drawingml/2006/main"/>
@@ -1929,6 +2001,7 @@
                 <a:spcPts val="0"/>
               </a:spcAft>
               <a:buNone/>
+              <a:defRPr/>
             </a:lvl1pPr>
             <a:lvl2pPr marL="0" indent="0">
               <a:lnSpc>
@@ -1941,6 +2014,7 @@
                 <a:spcPts val="0"/>
               </a:spcAft>
               <a:buNone/>
+              <a:defRPr/>
             </a:lvl2pPr>
             <a:lvl3pPr marL="0" indent="0">
               <a:lnSpc>
@@ -1953,6 +2027,7 @@
                 <a:spcPts val="0"/>
               </a:spcAft>
               <a:buNone/>
+              <a:defRPr/>
             </a:lvl3pPr>
             <a:lvl4pPr marL="0" indent="0">
               <a:lnSpc>
@@ -1965,6 +2040,7 @@
                 <a:spcPts val="0"/>
               </a:spcAft>
               <a:buNone/>
+              <a:defRPr/>
             </a:lvl4pPr>
             <a:lvl5pPr marL="0" indent="0">
               <a:lnSpc>
@@ -1977,6 +2053,7 @@
                 <a:spcPts val="0"/>
               </a:spcAft>
               <a:buNone/>
+              <a:defRPr/>
             </a:lvl5pPr>
             <a:lvl6pPr marL="0" indent="0">
               <a:lnSpc>
@@ -1989,6 +2066,7 @@
                 <a:spcPts val="0"/>
               </a:spcAft>
               <a:buNone/>
+              <a:defRPr/>
             </a:lvl6pPr>
             <a:lvl7pPr marL="0" indent="0">
               <a:lnSpc>
@@ -2001,6 +2079,7 @@
                 <a:spcPts val="0"/>
               </a:spcAft>
               <a:buNone/>
+              <a:defRPr/>
             </a:lvl7pPr>
             <a:lvl8pPr marL="0" indent="0">
               <a:lnSpc>
@@ -2013,6 +2092,7 @@
                 <a:spcPts val="0"/>
               </a:spcAft>
               <a:buNone/>
+              <a:defRPr/>
             </a:lvl8pPr>
             <a:lvl9pPr marL="0" indent="0">
               <a:lnSpc>
@@ -2025,6 +2105,7 @@
                 <a:spcPts val="0"/>
               </a:spcAft>
               <a:buNone/>
+              <a:defRPr/>
             </a:lvl9pPr>
           </a:lstStyle>
           <a:p xmlns:a="http://schemas.openxmlformats.org/drawingml/2006/main"/>
@@ -2076,6 +2157,7 @@
                 <a:spcPts val="1200"/>
               </a:spcAft>
               <a:buChar char="•"/>
+              <a:defRPr/>
             </a:lvl1pPr>
             <a:lvl2pPr marL="533400" indent="-228600">
               <a:lnSpc>
@@ -2088,6 +2170,7 @@
                 <a:spcPts val="1200"/>
               </a:spcAft>
               <a:buChar char="•"/>
+              <a:defRPr/>
             </a:lvl2pPr>
             <a:lvl3pPr marL="838200" indent="-228600">
               <a:lnSpc>
@@ -2100,6 +2183,7 @@
                 <a:spcPts val="1200"/>
               </a:spcAft>
               <a:buChar char="•"/>
+              <a:defRPr/>
             </a:lvl3pPr>
             <a:lvl4pPr marL="1143000" indent="-228600">
               <a:lnSpc>
@@ -2112,6 +2196,7 @@
                 <a:spcPts val="1200"/>
               </a:spcAft>
               <a:buChar char="•"/>
+              <a:defRPr/>
             </a:lvl4pPr>
             <a:lvl5pPr marL="1447800" indent="-228600">
               <a:lnSpc>
@@ -2124,6 +2209,7 @@
                 <a:spcPts val="1200"/>
               </a:spcAft>
               <a:buChar char="•"/>
+              <a:defRPr/>
             </a:lvl5pPr>
             <a:lvl6pPr marL="1752600" indent="-228600">
               <a:lnSpc>
@@ -2136,6 +2222,7 @@
                 <a:spcPts val="1200"/>
               </a:spcAft>
               <a:buChar char="•"/>
+              <a:defRPr/>
             </a:lvl6pPr>
             <a:lvl7pPr marL="2057400" indent="-228600">
               <a:lnSpc>
@@ -2148,6 +2235,7 @@
                 <a:spcPts val="1200"/>
               </a:spcAft>
               <a:buChar char="•"/>
+              <a:defRPr/>
             </a:lvl7pPr>
             <a:lvl8pPr marL="2362200" indent="-228600">
               <a:lnSpc>
@@ -2160,6 +2248,7 @@
                 <a:spcPts val="1200"/>
               </a:spcAft>
               <a:buChar char="•"/>
+              <a:defRPr/>
             </a:lvl8pPr>
             <a:lvl9pPr marL="2667000" indent="-228600">
               <a:lnSpc>
@@ -2172,6 +2261,7 @@
                 <a:spcPts val="1200"/>
               </a:spcAft>
               <a:buChar char="•"/>
+              <a:defRPr/>
             </a:lvl9pPr>
           </a:lstStyle>
           <a:p xmlns:a="http://schemas.openxmlformats.org/drawingml/2006/main"/>
@@ -2220,12 +2310,12 @@
   </p:cSld>
   <p:clrMap bg1="lt1" tx1="dk1" bg2="lt2" tx2="dk2" accent1="accent1" accent2="accent2" accent3="accent3" accent4="accent4" accent5="accent5" accent6="accent6" hlink="hlink" folHlink="folHlink"/>
   <p:sldLayoutIdLst>
-    <p:sldLayoutId xmlns:r="http://schemas.openxmlformats.org/officeDocument/2006/relationships" id="2147483649" r:id="Rd21e533e423b47b0"/>
-    <p:sldLayoutId xmlns:r="http://schemas.openxmlformats.org/officeDocument/2006/relationships" id="2147483650" r:id="Ra3fc6164ec1f43b6"/>
-    <p:sldLayoutId xmlns:r="http://schemas.openxmlformats.org/officeDocument/2006/relationships" id="2147483651" r:id="Rc7a53bd932c64c43"/>
-    <p:sldLayoutId xmlns:r="http://schemas.openxmlformats.org/officeDocument/2006/relationships" id="2147483652" r:id="Re22634414da649c2"/>
-    <p:sldLayoutId xmlns:r="http://schemas.openxmlformats.org/officeDocument/2006/relationships" id="2147483653" r:id="Racbf0751c74b409a"/>
-    <p:sldLayoutId xmlns:r="http://schemas.openxmlformats.org/officeDocument/2006/relationships" id="2147483654" r:id="Rc219be3b4db34a55"/>
+    <p:sldLayoutId xmlns:r="http://schemas.openxmlformats.org/officeDocument/2006/relationships" id="2147483649" r:id="Rc3064fa979284dc9"/>
+    <p:sldLayoutId xmlns:r="http://schemas.openxmlformats.org/officeDocument/2006/relationships" id="2147483650" r:id="Rb6306129fe364d37"/>
+    <p:sldLayoutId xmlns:r="http://schemas.openxmlformats.org/officeDocument/2006/relationships" id="2147483651" r:id="R0a0cf5914bcf42af"/>
+    <p:sldLayoutId xmlns:r="http://schemas.openxmlformats.org/officeDocument/2006/relationships" id="2147483652" r:id="Rceb4953f81e84c39"/>
+    <p:sldLayoutId xmlns:r="http://schemas.openxmlformats.org/officeDocument/2006/relationships" id="2147483653" r:id="R122ffa0489844db2"/>
+    <p:sldLayoutId xmlns:r="http://schemas.openxmlformats.org/officeDocument/2006/relationships" id="2147483654" r:id="Ra9ac8c7ff5c640c3"/>
   </p:sldLayoutIdLst>
   <p:txStyles>
     <p:titleStyle>
@@ -2805,6 +2895,7 @@
           <a:lstStyle xmlns:a="http://schemas.openxmlformats.org/drawingml/2006/main"/>
           <a:p xmlns:a="http://schemas.openxmlformats.org/drawingml/2006/main">
             <a:pPr>
+              <a:buNone/>
               <a:defRPr sz="3300" b="1">
                 <a:solidFill>
                   <a:srgbClr val="173B45"/>
@@ -2828,6 +2919,7 @@
           </a:p>
           <a:p xmlns:a="http://schemas.openxmlformats.org/drawingml/2006/main">
             <a:pPr>
+              <a:buNone/>
               <a:defRPr sz="3300" b="1">
                 <a:solidFill>
                   <a:srgbClr val="173B45"/>
@@ -2885,6 +2977,7 @@
           <a:lstStyle xmlns:a="http://schemas.openxmlformats.org/drawingml/2006/main"/>
           <a:p xmlns:a="http://schemas.openxmlformats.org/drawingml/2006/main">
             <a:pPr>
+              <a:buNone/>
               <a:defRPr sz="1800" b="0">
                 <a:solidFill>
                   <a:srgbClr val="173B45"/>
@@ -2910,7 +3003,13 @@
       </p:sp>
       <p:graphicFrame>
         <p:nvGraphicFramePr>
-          <p:cNvPr id="9" name=""/>
+          <p:cNvPr id="9" name="">
+            <a:extLst xmlns:a="http://schemas.openxmlformats.org/drawingml/2006/main">
+              <a:ext uri="{FF2B5EF4-FFF2-40B4-BE49-F238E27FC236}">
+                <a16:creationId xmlns:a16="http://schemas.microsoft.com/office/drawing/2014/main" id="{CD65B765-8C95-4985-A091-5B97FCFB111D}"/>
+              </a:ext>
+            </a:extLst>
+          </p:cNvPr>
           <p:cNvGraphicFramePr/>
           <p:nvPr/>
         </p:nvGraphicFramePr>
@@ -3494,6 +3593,7 @@
           <a:lstStyle xmlns:a="http://schemas.openxmlformats.org/drawingml/2006/main"/>
           <a:p xmlns:a="http://schemas.openxmlformats.org/drawingml/2006/main">
             <a:pPr>
+              <a:buNone/>
               <a:defRPr sz="2175" b="1">
                 <a:solidFill>
                   <a:srgbClr val="A4481B"/>
@@ -3512,7 +3612,7 @@
                 <a:ea typeface="DejaVu Sans"/>
                 <a:cs typeface="DejaVu Sans"/>
               </a:rPr>
-              <a:t>15.10: полный MVP с нуля не успевает. Go/no-go — 14.10.</a:t>
+              <a:t>План от 10.08: MVP 05.10. Открытие 15.10. Резерв 10 дней.</a:t>
             </a:r>
           </a:p>
         </p:txBody>
@@ -3551,6 +3651,7 @@
           <a:lstStyle xmlns:a="http://schemas.openxmlformats.org/drawingml/2006/main"/>
           <a:p xmlns:a="http://schemas.openxmlformats.org/drawingml/2006/main">
             <a:pPr>
+              <a:buNone/>
               <a:defRPr sz="1800" b="0">
                 <a:solidFill>
                   <a:srgbClr val="173B45"/>
@@ -3574,6 +3675,7 @@
           </a:p>
           <a:p xmlns:a="http://schemas.openxmlformats.org/drawingml/2006/main">
             <a:pPr>
+              <a:buNone/>
               <a:defRPr sz="1800" b="0">
                 <a:solidFill>
                   <a:srgbClr val="173B45"/>
@@ -3631,6 +3733,7 @@
           <a:lstStyle xmlns:a="http://schemas.openxmlformats.org/drawingml/2006/main"/>
           <a:p xmlns:a="http://schemas.openxmlformats.org/drawingml/2006/main">
             <a:pPr>
+              <a:buNone/>
               <a:defRPr sz="1275" b="0">
                 <a:solidFill>
                   <a:srgbClr val="52646A"/>
@@ -3654,6 +3757,7 @@
           </a:p>
           <a:p xmlns:a="http://schemas.openxmlformats.org/drawingml/2006/main">
             <a:pPr>
+              <a:buNone/>
               <a:defRPr sz="1275" b="0">
                 <a:solidFill>
                   <a:srgbClr val="52646A"/>

</xml_diff>